<commit_message>
Remove unused comments (Close #14)
</commit_message>
<xml_diff>
--- a/Documentation/Presentation.pptx
+++ b/Documentation/Presentation.pptx
@@ -160,7 +160,7 @@
           </a:lstStyle>
           <a:p>
             <a:r>
-              <a:rPr lang="bg-BG" smtClean="0"/>
+              <a:rPr lang="bg-BG"/>
               <a:t>Редакт. стил загл. образец</a:t>
             </a:r>
             <a:endParaRPr lang="en-US"/>
@@ -225,7 +225,7 @@
           </a:lstStyle>
           <a:p>
             <a:r>
-              <a:rPr lang="bg-BG" smtClean="0"/>
+              <a:rPr lang="bg-BG"/>
               <a:t>Щракнете, за да редактирате стила на подзаглавието в образеца</a:t>
             </a:r>
             <a:endParaRPr lang="en-US"/>
@@ -343,7 +343,7 @@
           <a:lstStyle/>
           <a:p>
             <a:r>
-              <a:rPr lang="bg-BG" smtClean="0"/>
+              <a:rPr lang="bg-BG"/>
               <a:t>Редакт. стил загл. образец</a:t>
             </a:r>
             <a:endParaRPr lang="en-US"/>
@@ -367,35 +367,35 @@
           <a:p>
             <a:pPr lvl="0"/>
             <a:r>
-              <a:rPr lang="bg-BG" smtClean="0"/>
+              <a:rPr lang="bg-BG"/>
               <a:t>Редактиране на стиловете на текста в образеца</a:t>
             </a:r>
           </a:p>
           <a:p>
             <a:pPr lvl="1"/>
             <a:r>
-              <a:rPr lang="bg-BG" smtClean="0"/>
+              <a:rPr lang="bg-BG"/>
               <a:t>Второ ниво</a:t>
             </a:r>
           </a:p>
           <a:p>
             <a:pPr lvl="2"/>
             <a:r>
-              <a:rPr lang="bg-BG" smtClean="0"/>
+              <a:rPr lang="bg-BG"/>
               <a:t>Трето ниво</a:t>
             </a:r>
           </a:p>
           <a:p>
             <a:pPr lvl="3"/>
             <a:r>
-              <a:rPr lang="bg-BG" smtClean="0"/>
+              <a:rPr lang="bg-BG"/>
               <a:t>Четвърто ниво</a:t>
             </a:r>
           </a:p>
           <a:p>
             <a:pPr lvl="4"/>
             <a:r>
-              <a:rPr lang="bg-BG" smtClean="0"/>
+              <a:rPr lang="bg-BG"/>
               <a:t>Пето ниво</a:t>
             </a:r>
             <a:endParaRPr lang="en-US"/>
@@ -518,7 +518,7 @@
           <a:lstStyle/>
           <a:p>
             <a:r>
-              <a:rPr lang="bg-BG" smtClean="0"/>
+              <a:rPr lang="bg-BG"/>
               <a:t>Редакт. стил загл. образец</a:t>
             </a:r>
             <a:endParaRPr lang="en-US"/>
@@ -547,35 +547,35 @@
           <a:p>
             <a:pPr lvl="0"/>
             <a:r>
-              <a:rPr lang="bg-BG" smtClean="0"/>
+              <a:rPr lang="bg-BG"/>
               <a:t>Редактиране на стиловете на текста в образеца</a:t>
             </a:r>
           </a:p>
           <a:p>
             <a:pPr lvl="1"/>
             <a:r>
-              <a:rPr lang="bg-BG" smtClean="0"/>
+              <a:rPr lang="bg-BG"/>
               <a:t>Второ ниво</a:t>
             </a:r>
           </a:p>
           <a:p>
             <a:pPr lvl="2"/>
             <a:r>
-              <a:rPr lang="bg-BG" smtClean="0"/>
+              <a:rPr lang="bg-BG"/>
               <a:t>Трето ниво</a:t>
             </a:r>
           </a:p>
           <a:p>
             <a:pPr lvl="3"/>
             <a:r>
-              <a:rPr lang="bg-BG" smtClean="0"/>
+              <a:rPr lang="bg-BG"/>
               <a:t>Четвърто ниво</a:t>
             </a:r>
           </a:p>
           <a:p>
             <a:pPr lvl="4"/>
             <a:r>
-              <a:rPr lang="bg-BG" smtClean="0"/>
+              <a:rPr lang="bg-BG"/>
               <a:t>Пето ниво</a:t>
             </a:r>
             <a:endParaRPr lang="en-US"/>
@@ -693,7 +693,7 @@
           <a:lstStyle/>
           <a:p>
             <a:r>
-              <a:rPr lang="bg-BG" smtClean="0"/>
+              <a:rPr lang="bg-BG"/>
               <a:t>Редакт. стил загл. образец</a:t>
             </a:r>
             <a:endParaRPr lang="en-US"/>
@@ -717,35 +717,35 @@
           <a:p>
             <a:pPr lvl="0"/>
             <a:r>
-              <a:rPr lang="bg-BG" smtClean="0"/>
+              <a:rPr lang="bg-BG"/>
               <a:t>Редактиране на стиловете на текста в образеца</a:t>
             </a:r>
           </a:p>
           <a:p>
             <a:pPr lvl="1"/>
             <a:r>
-              <a:rPr lang="bg-BG" smtClean="0"/>
+              <a:rPr lang="bg-BG"/>
               <a:t>Второ ниво</a:t>
             </a:r>
           </a:p>
           <a:p>
             <a:pPr lvl="2"/>
             <a:r>
-              <a:rPr lang="bg-BG" smtClean="0"/>
+              <a:rPr lang="bg-BG"/>
               <a:t>Трето ниво</a:t>
             </a:r>
           </a:p>
           <a:p>
             <a:pPr lvl="3"/>
             <a:r>
-              <a:rPr lang="bg-BG" smtClean="0"/>
+              <a:rPr lang="bg-BG"/>
               <a:t>Четвърто ниво</a:t>
             </a:r>
           </a:p>
           <a:p>
             <a:pPr lvl="4"/>
             <a:r>
-              <a:rPr lang="bg-BG" smtClean="0"/>
+              <a:rPr lang="bg-BG"/>
               <a:t>Пето ниво</a:t>
             </a:r>
             <a:endParaRPr lang="en-US"/>
@@ -872,7 +872,7 @@
           </a:lstStyle>
           <a:p>
             <a:r>
-              <a:rPr lang="bg-BG" smtClean="0"/>
+              <a:rPr lang="bg-BG"/>
               <a:t>Редакт. стил загл. образец</a:t>
             </a:r>
             <a:endParaRPr lang="en-US"/>
@@ -992,7 +992,7 @@
           <a:p>
             <a:pPr lvl="0"/>
             <a:r>
-              <a:rPr lang="bg-BG" smtClean="0"/>
+              <a:rPr lang="bg-BG"/>
               <a:t>Редактиране на стиловете на текста в образеца</a:t>
             </a:r>
           </a:p>
@@ -1109,7 +1109,7 @@
           <a:lstStyle/>
           <a:p>
             <a:r>
-              <a:rPr lang="bg-BG" smtClean="0"/>
+              <a:rPr lang="bg-BG"/>
               <a:t>Редакт. стил загл. образец</a:t>
             </a:r>
             <a:endParaRPr lang="en-US"/>
@@ -1138,35 +1138,35 @@
           <a:p>
             <a:pPr lvl="0"/>
             <a:r>
-              <a:rPr lang="bg-BG" smtClean="0"/>
+              <a:rPr lang="bg-BG"/>
               <a:t>Редактиране на стиловете на текста в образеца</a:t>
             </a:r>
           </a:p>
           <a:p>
             <a:pPr lvl="1"/>
             <a:r>
-              <a:rPr lang="bg-BG" smtClean="0"/>
+              <a:rPr lang="bg-BG"/>
               <a:t>Второ ниво</a:t>
             </a:r>
           </a:p>
           <a:p>
             <a:pPr lvl="2"/>
             <a:r>
-              <a:rPr lang="bg-BG" smtClean="0"/>
+              <a:rPr lang="bg-BG"/>
               <a:t>Трето ниво</a:t>
             </a:r>
           </a:p>
           <a:p>
             <a:pPr lvl="3"/>
             <a:r>
-              <a:rPr lang="bg-BG" smtClean="0"/>
+              <a:rPr lang="bg-BG"/>
               <a:t>Четвърто ниво</a:t>
             </a:r>
           </a:p>
           <a:p>
             <a:pPr lvl="4"/>
             <a:r>
-              <a:rPr lang="bg-BG" smtClean="0"/>
+              <a:rPr lang="bg-BG"/>
               <a:t>Пето ниво</a:t>
             </a:r>
             <a:endParaRPr lang="en-US"/>
@@ -1195,35 +1195,35 @@
           <a:p>
             <a:pPr lvl="0"/>
             <a:r>
-              <a:rPr lang="bg-BG" smtClean="0"/>
+              <a:rPr lang="bg-BG"/>
               <a:t>Редактиране на стиловете на текста в образеца</a:t>
             </a:r>
           </a:p>
           <a:p>
             <a:pPr lvl="1"/>
             <a:r>
-              <a:rPr lang="bg-BG" smtClean="0"/>
+              <a:rPr lang="bg-BG"/>
               <a:t>Второ ниво</a:t>
             </a:r>
           </a:p>
           <a:p>
             <a:pPr lvl="2"/>
             <a:r>
-              <a:rPr lang="bg-BG" smtClean="0"/>
+              <a:rPr lang="bg-BG"/>
               <a:t>Трето ниво</a:t>
             </a:r>
           </a:p>
           <a:p>
             <a:pPr lvl="3"/>
             <a:r>
-              <a:rPr lang="bg-BG" smtClean="0"/>
+              <a:rPr lang="bg-BG"/>
               <a:t>Четвърто ниво</a:t>
             </a:r>
           </a:p>
           <a:p>
             <a:pPr lvl="4"/>
             <a:r>
-              <a:rPr lang="bg-BG" smtClean="0"/>
+              <a:rPr lang="bg-BG"/>
               <a:t>Пето ниво</a:t>
             </a:r>
             <a:endParaRPr lang="en-US"/>
@@ -1346,7 +1346,7 @@
           <a:lstStyle/>
           <a:p>
             <a:r>
-              <a:rPr lang="bg-BG" smtClean="0"/>
+              <a:rPr lang="bg-BG"/>
               <a:t>Редакт. стил загл. образец</a:t>
             </a:r>
             <a:endParaRPr lang="en-US"/>
@@ -1412,7 +1412,7 @@
           <a:p>
             <a:pPr lvl="0"/>
             <a:r>
-              <a:rPr lang="bg-BG" smtClean="0"/>
+              <a:rPr lang="bg-BG"/>
               <a:t>Редактиране на стиловете на текста в образеца</a:t>
             </a:r>
           </a:p>
@@ -1440,35 +1440,35 @@
           <a:p>
             <a:pPr lvl="0"/>
             <a:r>
-              <a:rPr lang="bg-BG" smtClean="0"/>
+              <a:rPr lang="bg-BG"/>
               <a:t>Редактиране на стиловете на текста в образеца</a:t>
             </a:r>
           </a:p>
           <a:p>
             <a:pPr lvl="1"/>
             <a:r>
-              <a:rPr lang="bg-BG" smtClean="0"/>
+              <a:rPr lang="bg-BG"/>
               <a:t>Второ ниво</a:t>
             </a:r>
           </a:p>
           <a:p>
             <a:pPr lvl="2"/>
             <a:r>
-              <a:rPr lang="bg-BG" smtClean="0"/>
+              <a:rPr lang="bg-BG"/>
               <a:t>Трето ниво</a:t>
             </a:r>
           </a:p>
           <a:p>
             <a:pPr lvl="3"/>
             <a:r>
-              <a:rPr lang="bg-BG" smtClean="0"/>
+              <a:rPr lang="bg-BG"/>
               <a:t>Четвърто ниво</a:t>
             </a:r>
           </a:p>
           <a:p>
             <a:pPr lvl="4"/>
             <a:r>
-              <a:rPr lang="bg-BG" smtClean="0"/>
+              <a:rPr lang="bg-BG"/>
               <a:t>Пето ниво</a:t>
             </a:r>
             <a:endParaRPr lang="en-US"/>
@@ -1534,7 +1534,7 @@
           <a:p>
             <a:pPr lvl="0"/>
             <a:r>
-              <a:rPr lang="bg-BG" smtClean="0"/>
+              <a:rPr lang="bg-BG"/>
               <a:t>Редактиране на стиловете на текста в образеца</a:t>
             </a:r>
           </a:p>
@@ -1562,35 +1562,35 @@
           <a:p>
             <a:pPr lvl="0"/>
             <a:r>
-              <a:rPr lang="bg-BG" smtClean="0"/>
+              <a:rPr lang="bg-BG"/>
               <a:t>Редактиране на стиловете на текста в образеца</a:t>
             </a:r>
           </a:p>
           <a:p>
             <a:pPr lvl="1"/>
             <a:r>
-              <a:rPr lang="bg-BG" smtClean="0"/>
+              <a:rPr lang="bg-BG"/>
               <a:t>Второ ниво</a:t>
             </a:r>
           </a:p>
           <a:p>
             <a:pPr lvl="2"/>
             <a:r>
-              <a:rPr lang="bg-BG" smtClean="0"/>
+              <a:rPr lang="bg-BG"/>
               <a:t>Трето ниво</a:t>
             </a:r>
           </a:p>
           <a:p>
             <a:pPr lvl="3"/>
             <a:r>
-              <a:rPr lang="bg-BG" smtClean="0"/>
+              <a:rPr lang="bg-BG"/>
               <a:t>Четвърто ниво</a:t>
             </a:r>
           </a:p>
           <a:p>
             <a:pPr lvl="4"/>
             <a:r>
-              <a:rPr lang="bg-BG" smtClean="0"/>
+              <a:rPr lang="bg-BG"/>
               <a:t>Пето ниво</a:t>
             </a:r>
             <a:endParaRPr lang="en-US"/>
@@ -1708,7 +1708,7 @@
           <a:lstStyle/>
           <a:p>
             <a:r>
-              <a:rPr lang="bg-BG" smtClean="0"/>
+              <a:rPr lang="bg-BG"/>
               <a:t>Редакт. стил загл. образец</a:t>
             </a:r>
             <a:endParaRPr lang="en-US"/>
@@ -1930,7 +1930,7 @@
           </a:lstStyle>
           <a:p>
             <a:r>
-              <a:rPr lang="bg-BG" smtClean="0"/>
+              <a:rPr lang="bg-BG"/>
               <a:t>Редакт. стил загл. образец</a:t>
             </a:r>
             <a:endParaRPr lang="en-US"/>
@@ -1987,35 +1987,35 @@
           <a:p>
             <a:pPr lvl="0"/>
             <a:r>
-              <a:rPr lang="bg-BG" smtClean="0"/>
+              <a:rPr lang="bg-BG"/>
               <a:t>Редактиране на стиловете на текста в образеца</a:t>
             </a:r>
           </a:p>
           <a:p>
             <a:pPr lvl="1"/>
             <a:r>
-              <a:rPr lang="bg-BG" smtClean="0"/>
+              <a:rPr lang="bg-BG"/>
               <a:t>Второ ниво</a:t>
             </a:r>
           </a:p>
           <a:p>
             <a:pPr lvl="2"/>
             <a:r>
-              <a:rPr lang="bg-BG" smtClean="0"/>
+              <a:rPr lang="bg-BG"/>
               <a:t>Трето ниво</a:t>
             </a:r>
           </a:p>
           <a:p>
             <a:pPr lvl="3"/>
             <a:r>
-              <a:rPr lang="bg-BG" smtClean="0"/>
+              <a:rPr lang="bg-BG"/>
               <a:t>Четвърто ниво</a:t>
             </a:r>
           </a:p>
           <a:p>
             <a:pPr lvl="4"/>
             <a:r>
-              <a:rPr lang="bg-BG" smtClean="0"/>
+              <a:rPr lang="bg-BG"/>
               <a:t>Пето ниво</a:t>
             </a:r>
             <a:endParaRPr lang="en-US"/>
@@ -2081,7 +2081,7 @@
           <a:p>
             <a:pPr lvl="0"/>
             <a:r>
-              <a:rPr lang="bg-BG" smtClean="0"/>
+              <a:rPr lang="bg-BG"/>
               <a:t>Редактиране на стиловете на текста в образеца</a:t>
             </a:r>
           </a:p>
@@ -2207,7 +2207,7 @@
           </a:lstStyle>
           <a:p>
             <a:r>
-              <a:rPr lang="bg-BG" smtClean="0"/>
+              <a:rPr lang="bg-BG"/>
               <a:t>Редакт. стил загл. образец</a:t>
             </a:r>
             <a:endParaRPr lang="en-US"/>
@@ -2334,7 +2334,7 @@
           <a:p>
             <a:pPr lvl="0"/>
             <a:r>
-              <a:rPr lang="bg-BG" smtClean="0"/>
+              <a:rPr lang="bg-BG"/>
               <a:t>Редактиране на стиловете на текста в образеца</a:t>
             </a:r>
           </a:p>
@@ -2466,7 +2466,7 @@
           <a:lstStyle/>
           <a:p>
             <a:r>
-              <a:rPr lang="bg-BG" smtClean="0"/>
+              <a:rPr lang="bg-BG"/>
               <a:t>Редакт. стил загл. образец</a:t>
             </a:r>
             <a:endParaRPr lang="en-US"/>
@@ -2500,35 +2500,35 @@
           <a:p>
             <a:pPr lvl="0"/>
             <a:r>
-              <a:rPr lang="bg-BG" smtClean="0"/>
+              <a:rPr lang="bg-BG"/>
               <a:t>Редактиране на стиловете на текста в образеца</a:t>
             </a:r>
           </a:p>
           <a:p>
             <a:pPr lvl="1"/>
             <a:r>
-              <a:rPr lang="bg-BG" smtClean="0"/>
+              <a:rPr lang="bg-BG"/>
               <a:t>Второ ниво</a:t>
             </a:r>
           </a:p>
           <a:p>
             <a:pPr lvl="2"/>
             <a:r>
-              <a:rPr lang="bg-BG" smtClean="0"/>
+              <a:rPr lang="bg-BG"/>
               <a:t>Трето ниво</a:t>
             </a:r>
           </a:p>
           <a:p>
             <a:pPr lvl="3"/>
             <a:r>
-              <a:rPr lang="bg-BG" smtClean="0"/>
+              <a:rPr lang="bg-BG"/>
               <a:t>Четвърто ниво</a:t>
             </a:r>
           </a:p>
           <a:p>
             <a:pPr lvl="4"/>
             <a:r>
-              <a:rPr lang="bg-BG" smtClean="0"/>
+              <a:rPr lang="bg-BG"/>
               <a:t>Пето ниво</a:t>
             </a:r>
             <a:endParaRPr lang="en-US"/>
@@ -3009,13 +3009,6 @@
   <p:clrMapOvr>
     <a:masterClrMapping/>
   </p:clrMapOvr>
-  <p:timing>
-    <p:tnLst>
-      <p:par>
-        <p:cTn id="1" dur="indefinite" restart="never" nodeType="tmRoot"/>
-      </p:par>
-    </p:tnLst>
-  </p:timing>
 </p:sld>
 </file>
 
@@ -3052,7 +3045,7 @@
         </p:blipFill>
         <p:spPr>
           <a:xfrm>
-            <a:off x="1" y="-19283"/>
+            <a:off x="0" y="-19284"/>
             <a:ext cx="12192000" cy="6877284"/>
           </a:xfrm>
           <a:prstGeom prst="rect">
@@ -3070,13 +3063,6 @@
   <p:clrMapOvr>
     <a:masterClrMapping/>
   </p:clrMapOvr>
-  <p:timing>
-    <p:tnLst>
-      <p:par>
-        <p:cTn id="1" dur="indefinite" restart="never" nodeType="tmRoot"/>
-      </p:par>
-    </p:tnLst>
-  </p:timing>
 </p:sld>
 </file>
 
@@ -3137,13 +3123,6 @@
   <p:clrMapOvr>
     <a:masterClrMapping/>
   </p:clrMapOvr>
-  <p:timing>
-    <p:tnLst>
-      <p:par>
-        <p:cTn id="1" dur="indefinite" restart="never" nodeType="tmRoot"/>
-      </p:par>
-    </p:tnLst>
-  </p:timing>
 </p:sld>
 </file>
 
@@ -3204,13 +3183,6 @@
   <p:clrMapOvr>
     <a:masterClrMapping/>
   </p:clrMapOvr>
-  <p:timing>
-    <p:tnLst>
-      <p:par>
-        <p:cTn id="1" dur="indefinite" restart="never" nodeType="tmRoot"/>
-      </p:par>
-    </p:tnLst>
-  </p:timing>
 </p:sld>
 </file>
 
@@ -3265,13 +3237,6 @@
   <p:clrMapOvr>
     <a:masterClrMapping/>
   </p:clrMapOvr>
-  <p:timing>
-    <p:tnLst>
-      <p:par>
-        <p:cTn id="1" dur="indefinite" restart="never" nodeType="tmRoot"/>
-      </p:par>
-    </p:tnLst>
-  </p:timing>
 </p:sld>
 </file>
 
@@ -3326,13 +3291,6 @@
   <p:clrMapOvr>
     <a:masterClrMapping/>
   </p:clrMapOvr>
-  <p:timing>
-    <p:tnLst>
-      <p:par>
-        <p:cTn id="1" dur="indefinite" restart="never" nodeType="tmRoot"/>
-      </p:par>
-    </p:tnLst>
-  </p:timing>
 </p:sld>
 </file>
 
@@ -3387,13 +3345,6 @@
   <p:clrMapOvr>
     <a:masterClrMapping/>
   </p:clrMapOvr>
-  <p:timing>
-    <p:tnLst>
-      <p:par>
-        <p:cTn id="1" dur="indefinite" restart="never" nodeType="tmRoot"/>
-      </p:par>
-    </p:tnLst>
-  </p:timing>
 </p:sld>
 </file>
 

</xml_diff>

<commit_message>
Enhance presentation content (Close #17)
</commit_message>
<xml_diff>
--- a/Documentation/Presentation.pptx
+++ b/Documentation/Presentation.pptx
@@ -9,9 +9,9 @@
     <p:sldId id="258" r:id="rId3"/>
     <p:sldId id="259" r:id="rId4"/>
     <p:sldId id="260" r:id="rId5"/>
-    <p:sldId id="261" r:id="rId6"/>
-    <p:sldId id="262" r:id="rId7"/>
-    <p:sldId id="263" r:id="rId8"/>
+    <p:sldId id="262" r:id="rId6"/>
+    <p:sldId id="263" r:id="rId7"/>
+    <p:sldId id="261" r:id="rId8"/>
   </p:sldIdLst>
   <p:sldSz cx="12192000" cy="6858000"/>
   <p:notesSz cx="6858000" cy="9144000"/>
@@ -249,7 +249,7 @@
           <a:p>
             <a:fld id="{06016D9C-4D83-4D4F-BDD9-AD96C6A897D7}" type="datetimeFigureOut">
               <a:rPr lang="en-US" smtClean="0"/>
-              <a:t>3/18/2026</a:t>
+              <a:t>3/23/2026</a:t>
             </a:fld>
             <a:endParaRPr lang="en-US"/>
           </a:p>
@@ -419,7 +419,7 @@
           <a:p>
             <a:fld id="{06016D9C-4D83-4D4F-BDD9-AD96C6A897D7}" type="datetimeFigureOut">
               <a:rPr lang="en-US" smtClean="0"/>
-              <a:t>3/18/2026</a:t>
+              <a:t>3/23/2026</a:t>
             </a:fld>
             <a:endParaRPr lang="en-US"/>
           </a:p>
@@ -599,7 +599,7 @@
           <a:p>
             <a:fld id="{06016D9C-4D83-4D4F-BDD9-AD96C6A897D7}" type="datetimeFigureOut">
               <a:rPr lang="en-US" smtClean="0"/>
-              <a:t>3/18/2026</a:t>
+              <a:t>3/23/2026</a:t>
             </a:fld>
             <a:endParaRPr lang="en-US"/>
           </a:p>
@@ -769,7 +769,7 @@
           <a:p>
             <a:fld id="{06016D9C-4D83-4D4F-BDD9-AD96C6A897D7}" type="datetimeFigureOut">
               <a:rPr lang="en-US" smtClean="0"/>
-              <a:t>3/18/2026</a:t>
+              <a:t>3/23/2026</a:t>
             </a:fld>
             <a:endParaRPr lang="en-US"/>
           </a:p>
@@ -1015,7 +1015,7 @@
           <a:p>
             <a:fld id="{06016D9C-4D83-4D4F-BDD9-AD96C6A897D7}" type="datetimeFigureOut">
               <a:rPr lang="en-US" smtClean="0"/>
-              <a:t>3/18/2026</a:t>
+              <a:t>3/23/2026</a:t>
             </a:fld>
             <a:endParaRPr lang="en-US"/>
           </a:p>
@@ -1247,7 +1247,7 @@
           <a:p>
             <a:fld id="{06016D9C-4D83-4D4F-BDD9-AD96C6A897D7}" type="datetimeFigureOut">
               <a:rPr lang="en-US" smtClean="0"/>
-              <a:t>3/18/2026</a:t>
+              <a:t>3/23/2026</a:t>
             </a:fld>
             <a:endParaRPr lang="en-US"/>
           </a:p>
@@ -1614,7 +1614,7 @@
           <a:p>
             <a:fld id="{06016D9C-4D83-4D4F-BDD9-AD96C6A897D7}" type="datetimeFigureOut">
               <a:rPr lang="en-US" smtClean="0"/>
-              <a:t>3/18/2026</a:t>
+              <a:t>3/23/2026</a:t>
             </a:fld>
             <a:endParaRPr lang="en-US"/>
           </a:p>
@@ -1732,7 +1732,7 @@
           <a:p>
             <a:fld id="{06016D9C-4D83-4D4F-BDD9-AD96C6A897D7}" type="datetimeFigureOut">
               <a:rPr lang="en-US" smtClean="0"/>
-              <a:t>3/18/2026</a:t>
+              <a:t>3/23/2026</a:t>
             </a:fld>
             <a:endParaRPr lang="en-US"/>
           </a:p>
@@ -1827,7 +1827,7 @@
           <a:p>
             <a:fld id="{06016D9C-4D83-4D4F-BDD9-AD96C6A897D7}" type="datetimeFigureOut">
               <a:rPr lang="en-US" smtClean="0"/>
-              <a:t>3/18/2026</a:t>
+              <a:t>3/23/2026</a:t>
             </a:fld>
             <a:endParaRPr lang="en-US"/>
           </a:p>
@@ -2104,7 +2104,7 @@
           <a:p>
             <a:fld id="{06016D9C-4D83-4D4F-BDD9-AD96C6A897D7}" type="datetimeFigureOut">
               <a:rPr lang="en-US" smtClean="0"/>
-              <a:t>3/18/2026</a:t>
+              <a:t>3/23/2026</a:t>
             </a:fld>
             <a:endParaRPr lang="en-US"/>
           </a:p>
@@ -2357,7 +2357,7 @@
           <a:p>
             <a:fld id="{06016D9C-4D83-4D4F-BDD9-AD96C6A897D7}" type="datetimeFigureOut">
               <a:rPr lang="en-US" smtClean="0"/>
-              <a:t>3/18/2026</a:t>
+              <a:t>3/23/2026</a:t>
             </a:fld>
             <a:endParaRPr lang="en-US"/>
           </a:p>
@@ -2570,7 +2570,7 @@
           <a:p>
             <a:fld id="{06016D9C-4D83-4D4F-BDD9-AD96C6A897D7}" type="datetimeFigureOut">
               <a:rPr lang="en-US" smtClean="0"/>
-              <a:t>3/18/2026</a:t>
+              <a:t>3/23/2026</a:t>
             </a:fld>
             <a:endParaRPr lang="en-US"/>
           </a:p>
@@ -3085,7 +3085,7 @@
       </p:grpSpPr>
       <p:pic>
         <p:nvPicPr>
-          <p:cNvPr id="2" name="Картина 1"/>
+          <p:cNvPr id="3" name="Картина 2"/>
           <p:cNvPicPr>
             <a:picLocks noChangeAspect="1"/>
           </p:cNvPicPr>
@@ -3145,7 +3145,7 @@
       </p:grpSpPr>
       <p:pic>
         <p:nvPicPr>
-          <p:cNvPr id="2" name="Картина 1"/>
+          <p:cNvPr id="3" name="Картина 2"/>
           <p:cNvPicPr>
             <a:picLocks noChangeAspect="1"/>
           </p:cNvPicPr>
@@ -3205,14 +3205,20 @@
       </p:grpSpPr>
       <p:pic>
         <p:nvPicPr>
-          <p:cNvPr id="3" name="Картина 2"/>
+          <p:cNvPr id="2" name="Картина 1"/>
           <p:cNvPicPr>
             <a:picLocks noChangeAspect="1"/>
           </p:cNvPicPr>
           <p:nvPr/>
         </p:nvPicPr>
         <p:blipFill>
-          <a:blip r:embed="rId2"/>
+          <a:blip r:embed="rId2">
+            <a:extLst>
+              <a:ext uri="{28A0092B-C50C-407E-A947-70E740481C1C}">
+                <a14:useLocalDpi xmlns:a14="http://schemas.microsoft.com/office/drawing/2010/main" val="0"/>
+              </a:ext>
+            </a:extLst>
+          </a:blip>
           <a:stretch>
             <a:fillRect/>
           </a:stretch>
@@ -3220,7 +3226,7 @@
         <p:spPr>
           <a:xfrm>
             <a:off x="0" y="0"/>
-            <a:ext cx="12218621" cy="6858000"/>
+            <a:ext cx="12192000" cy="6858000"/>
           </a:xfrm>
           <a:prstGeom prst="rect">
             <a:avLst/>
@@ -3230,7 +3236,7 @@
     </p:spTree>
     <p:extLst>
       <p:ext uri="{BB962C8B-B14F-4D97-AF65-F5344CB8AC3E}">
-        <p14:creationId xmlns:p14="http://schemas.microsoft.com/office/powerpoint/2010/main" val="1100137923"/>
+        <p14:creationId xmlns:p14="http://schemas.microsoft.com/office/powerpoint/2010/main" val="1963860035"/>
       </p:ext>
     </p:extLst>
   </p:cSld>
@@ -3259,22 +3265,28 @@
       </p:grpSpPr>
       <p:pic>
         <p:nvPicPr>
-          <p:cNvPr id="3" name="Картина 2"/>
+          <p:cNvPr id="2" name="Картина 1"/>
           <p:cNvPicPr>
             <a:picLocks noChangeAspect="1"/>
           </p:cNvPicPr>
           <p:nvPr/>
         </p:nvPicPr>
         <p:blipFill>
-          <a:blip r:embed="rId2"/>
+          <a:blip r:embed="rId2">
+            <a:extLst>
+              <a:ext uri="{28A0092B-C50C-407E-A947-70E740481C1C}">
+                <a14:useLocalDpi xmlns:a14="http://schemas.microsoft.com/office/drawing/2010/main" val="0"/>
+              </a:ext>
+            </a:extLst>
+          </a:blip>
           <a:stretch>
             <a:fillRect/>
           </a:stretch>
         </p:blipFill>
         <p:spPr>
           <a:xfrm>
-            <a:off x="-18302" y="0"/>
-            <a:ext cx="12228604" cy="6858000"/>
+            <a:off x="0" y="0"/>
+            <a:ext cx="12192000" cy="6858000"/>
           </a:xfrm>
           <a:prstGeom prst="rect">
             <a:avLst/>
@@ -3284,7 +3296,7 @@
     </p:spTree>
     <p:extLst>
       <p:ext uri="{BB962C8B-B14F-4D97-AF65-F5344CB8AC3E}">
-        <p14:creationId xmlns:p14="http://schemas.microsoft.com/office/powerpoint/2010/main" val="1963860035"/>
+        <p14:creationId xmlns:p14="http://schemas.microsoft.com/office/powerpoint/2010/main" val="1461838031"/>
       </p:ext>
     </p:extLst>
   </p:cSld>
@@ -3327,8 +3339,8 @@
         </p:blipFill>
         <p:spPr>
           <a:xfrm>
-            <a:off x="0" y="-4666"/>
-            <a:ext cx="12183719" cy="6862666"/>
+            <a:off x="0" y="0"/>
+            <a:ext cx="12218621" cy="6858000"/>
           </a:xfrm>
           <a:prstGeom prst="rect">
             <a:avLst/>
@@ -3338,7 +3350,7 @@
     </p:spTree>
     <p:extLst>
       <p:ext uri="{BB962C8B-B14F-4D97-AF65-F5344CB8AC3E}">
-        <p14:creationId xmlns:p14="http://schemas.microsoft.com/office/powerpoint/2010/main" val="1461838031"/>
+        <p14:creationId xmlns:p14="http://schemas.microsoft.com/office/powerpoint/2010/main" val="1100137923"/>
       </p:ext>
     </p:extLst>
   </p:cSld>

</xml_diff>